<commit_message>
Apresentação: retirar referência ao Regulamento de TFC
Co-Authored-By: Claude Opus 5.5 <noreply@anthropic.com>
Claude-Session: https://claude.ai/code/session_01RTNCrmFuFcvA7Trjn3iBm1
</commit_message>
<xml_diff>
--- a/docs/Apresentacao_Defesa_UAN.pptx
+++ b/docs/Apresentacao_Defesa_UAN.pptx
@@ -126,31 +126,31 @@
   <p:extLst>
     <p:ext uri="{521415D9-36F7-43E2-AB2F-B90AF26B5E84}">
       <p14:sectionLst xmlns:p14="http://schemas.microsoft.com/office/powerpoint/2010/main">
-        <p14:section name="Abertura" id="{ece288be-b6c1-285c-23e8-123e495d995e}">
+        <p14:section name="Abertura" id="{3059b6d1-a572-f85b-ed4e-9cd7c4a8857a}">
           <p14:sldIdLst>
             <p14:sldId id="256"/>
             <p14:sldId id="257"/>
           </p14:sldIdLst>
         </p14:section>
-        <p14:section name="Introdução" id="{25e6835f-6ef8-b66a-9461-c793e8906d56}">
+        <p14:section name="Introdução" id="{0c0bd8f1-29b3-28db-9889-d2901dcadd50}">
           <p14:sldIdLst>
             <p14:sldId id="258"/>
             <p14:sldId id="259"/>
           </p14:sldIdLst>
         </p14:section>
-        <p14:section name="Revisão da literatura" id="{3eed537e-5aed-8c94-4337-25344f667966}">
+        <p14:section name="Revisão da literatura" id="{09f18a88-dc9a-c8bd-8332-a48d6a4cd3e9}">
           <p14:sldIdLst>
             <p14:sldId id="260"/>
           </p14:sldIdLst>
         </p14:section>
-        <p14:section name="Metodologia" id="{a677c6a7-976f-f000-7a1f-222f31a2a3c3}">
+        <p14:section name="Metodologia" id="{2a9ea856-7e6f-fb57-1da7-f5242c8ade84}">
           <p14:sldIdLst>
             <p14:sldId id="261"/>
             <p14:sldId id="262"/>
             <p14:sldId id="263"/>
           </p14:sldIdLst>
         </p14:section>
-        <p14:section name="Resultados" id="{521dc923-22b1-a1ee-a84b-1eddbec10fcc}">
+        <p14:section name="Resultados" id="{6125120a-89de-a957-57eb-c1371e4baea6}">
           <p14:sldIdLst>
             <p14:sldId id="264"/>
             <p14:sldId id="265"/>
@@ -158,20 +158,20 @@
             <p14:sldId id="267"/>
           </p14:sldIdLst>
         </p14:section>
-        <p14:section name="Sistema" id="{22b89001-3ae1-244f-a861-3416b1cf15f8}">
+        <p14:section name="Sistema" id="{908704bf-8d8e-434a-5916-418510488582}">
           <p14:sldIdLst>
             <p14:sldId id="268"/>
             <p14:sldId id="269"/>
           </p14:sldIdLst>
         </p14:section>
-        <p14:section name="Conclusões" id="{17121ae2-4fbe-2c29-4301-012760c83646}">
+        <p14:section name="Conclusões" id="{50f60efb-a83e-fc1c-1b4b-6e101ba06450}">
           <p14:sldIdLst>
             <p14:sldId id="270"/>
             <p14:sldId id="271"/>
             <p14:sldId id="272"/>
           </p14:sldIdLst>
         </p14:section>
-        <p14:section name="Reserva" id="{af9104ac-d0ef-52b7-4c18-c56e6a8ee166}">
+        <p14:section name="Reserva" id="{f1c87b25-5e39-bba3-6a98-c5463e1d2160}">
           <p14:sldIdLst>
             <p14:sldId id="273"/>
             <p14:sldId id="274"/>
@@ -15040,7 +15040,7 @@
                   <a:srgbClr val="5B6B7F"/>
                 </a:solidFill>
               </a:rPr>
-              <a:t>Exposição: 15 minutos (artigo 17.º do Regulamento de Trabalhos de Fim de Curso da UAN). Os tempos à direita somam 14:45; os 15 segundos restantes cobrem a passagem para a demonstração.</a:t>
+              <a:t>Exposição: 15 minutos. Os tempos à direita somam 14:45; os 15 segundos restantes cobrem a passagem para a demonstração.</a:t>
             </a:r>
             <a:endParaRPr lang="en-US" sz="1100" dirty="0"/>
           </a:p>

</xml_diff>

<commit_message>
Apresentação actualizada (sementes, IC da lacuna, só YouTube, calibração no piloto, Capítulo 6, citações verificadas); dissertação: princípios SOCMINT de Omand et al. completos
Co-Authored-By: Claude Opus 5.5 <noreply@anthropic.com>
Claude-Session: https://claude.ai/code/session_01RTNCrmFuFcvA7Trjn3iBm1
</commit_message>
<xml_diff>
--- a/docs/Apresentacao_Defesa_UAN.pptx
+++ b/docs/Apresentacao_Defesa_UAN.pptx
@@ -129,32 +129,32 @@
   <p:extLst>
     <p:ext uri="{521415D9-36F7-43E2-AB2F-B90AF26B5E84}">
       <p14:sectionLst xmlns:p14="http://schemas.microsoft.com/office/powerpoint/2010/main">
-        <p14:section name="Abertura" id="{c6d7aff2-2d76-48fe-603b-93d9a6b53260}">
+        <p14:section name="Abertura" id="{865893e8-76a8-51ed-e8d4-6703d2c3c5a4}">
           <p14:sldIdLst>
             <p14:sldId id="256"/>
             <p14:sldId id="257"/>
           </p14:sldIdLst>
         </p14:section>
-        <p14:section name="Introdução" id="{ce67a014-a57b-b01f-3ba3-3a634784cc75}">
+        <p14:section name="Introdução" id="{9b9e195b-c772-f9b3-bf41-4973622e2c35}">
           <p14:sldIdLst>
             <p14:sldId id="258"/>
             <p14:sldId id="259"/>
             <p14:sldId id="260"/>
           </p14:sldIdLst>
         </p14:section>
-        <p14:section name="Revisão da literatura" id="{5507edbe-414a-799b-16a9-6453be90a794}">
+        <p14:section name="Revisão da literatura" id="{e11dc113-e914-2e49-3b9f-c2453ae44ef2}">
           <p14:sldIdLst>
             <p14:sldId id="261"/>
           </p14:sldIdLst>
         </p14:section>
-        <p14:section name="Metodologia" id="{181c0ce3-936a-0f3f-5d9d-7a017368a933}">
+        <p14:section name="Metodologia" id="{8edb41fd-ea69-66b2-4130-77b30df1b671}">
           <p14:sldIdLst>
             <p14:sldId id="262"/>
             <p14:sldId id="263"/>
             <p14:sldId id="264"/>
           </p14:sldIdLst>
         </p14:section>
-        <p14:section name="Resultados" id="{2abfb4e2-5d7d-0093-57d5-a0627dda8215}">
+        <p14:section name="Resultados" id="{105a8637-253d-7100-3c2e-f99200850288}">
           <p14:sldIdLst>
             <p14:sldId id="265"/>
             <p14:sldId id="266"/>
@@ -163,13 +163,13 @@
             <p14:sldId id="269"/>
           </p14:sldIdLst>
         </p14:section>
-        <p14:section name="Sistema" id="{6660c81a-b5ad-7408-4f01-5b13f6fa4633}">
+        <p14:section name="Sistema" id="{83db58ee-b8d6-341e-2bc0-e5ab891da144}">
           <p14:sldIdLst>
             <p14:sldId id="270"/>
             <p14:sldId id="271"/>
           </p14:sldIdLst>
         </p14:section>
-        <p14:section name="Conclusões" id="{b6c6fb05-20b3-bf72-6287-33e8628d4cd8}">
+        <p14:section name="Conclusões" id="{9b7c28c7-9832-a889-3819-45d3cb5f8307}">
           <p14:sldIdLst>
             <p14:sldId id="272"/>
             <p14:sldId id="273"/>
@@ -177,7 +177,7 @@
             <p14:sldId id="275"/>
           </p14:sldIdLst>
         </p14:section>
-        <p14:section name="Reserva" id="{248be05e-9cb4-3c3f-619b-65cc56626a55}">
+        <p14:section name="Reserva" id="{795cbd46-03a0-0c0e-0424-25e437daadf6}">
           <p14:sldIdLst>
             <p14:sldId id="276"/>
             <p14:sldId id="277"/>
@@ -2503,7 +2503,7 @@
             <a:r>
               <a:rPr lang="en-US" dirty="0"/>
               <a:t>Tempo deste diapositivo: 1:00 (relógio no fim: 8:45 de 20:00).
-O BERTimbau obteve F1-macro de 0,807, com intervalo que não se sobrepõe aos outros; a diferença é de 14,6 a 17,4 p.p., com p &lt; 10^-47. O Bi-LSTM não se distingue da Floresta Aleatória: por isso a H1 fica parcialmente confirmada. A explicação provável é o pré-treino.</a:t>
+O BERTimbau obteve F1-macro de 0,807, com intervalo que não se sobrepõe aos outros; a diferença é de 14,6 a 17,4 p.p., com p &lt; 10^-47. O Bi-LSTM não se distingue da Floresta Aleatória e, repetido com três sementes, nunca a supera: por isso a H1 fica parcialmente confirmada. Uma explicação plausível, que o desenho não isola, é o pré-treino. A média do BERTimbau em três sementes é 0,797.</a:t>
             </a:r>
             <a:endParaRPr lang="en-US" dirty="0"/>
           </a:p>
@@ -2592,7 +2592,7 @@
             <a:r>
               <a:rPr lang="en-US" dirty="0"/>
               <a:t>Tempo deste diapositivo: 1:00 (relógio no fim: 9:45 de 20:00).
-Este é o resultado central. No corpus público o F1-macro é 0,919; no piloto angolano cai para 0,533: 38,6 pontos. A maior queda é na Desinformação, de 0,99 para 0,24: o modelo aprendeu o estilo das notícias do Fake.br, não o fenómeno. A estimativa realista para Angola é 0,53, e é essa que o sistema mostra ao analista.</a:t>
+Este é o resultado central. No corpus público o F1-macro é 0,919; no piloto angolano cai para 0,533: 38,6 pontos. Sem a Mobilização Hostil a diferença mantém-se: 37,3 pontos, com IC de 30,6 a 44,7. Só com os comentários do YouTube sorteados o F1 é 0,535: os itens escolhidos por mim não explicam a lacuna. A maior queda é na Desinformação, de 0,99 para 0,24. Há duas explicações que os dados não separam: o modelo pode ter aprendido o estilo das notícias do Fake.br, ou as etiquetas do piloto são mais amplas. A estimativa realista para Angola é 0,53, e é essa que o sistema mostra ao analista.</a:t>
             </a:r>
             <a:endParaRPr lang="en-US" dirty="0"/>
           </a:p>
@@ -2681,7 +2681,7 @@
             <a:r>
               <a:rPr lang="en-US" dirty="0"/>
               <a:t>Tempo deste diapositivo: 0:50 (relógio no fim: 10:35 de 20:00).
-Como o sistema usa as probabilidades para ordenar a fila, medi também o esforço de revisão. Com o BERTimbau, rever um quarto da fila encontra 80% das ameaças. Mas a ordem reflecte a confiança e não a gravidade: a Mobilização Hostil fica a meio da fila. E 11,8% das ameaças ficam entre os itens que o modelo considera Normais: é isso que justifica a amostra de controlo.</a:t>
+Como o sistema usa as probabilidades para ordenar a fila, medi também o esforço de revisão. Numa ordenação de todo o teste, com o BERTimbau, rever um quarto encontra 80% das ameaças. Mas a ordem reflecte a confiança e não a gravidade: a Mobilização Hostil fica a meio. E no piloto angolano é pior: é preciso rever 49% para o mesmo resultado, e 28,7% das ameaças ficam entre os itens que o modelo considera Normais, contra 11,8% no teste completo. É isso que justifica a amostra de controlo.</a:t>
             </a:r>
             <a:endParaRPr lang="en-US" dirty="0"/>
           </a:p>
@@ -2770,7 +2770,7 @@
             <a:r>
               <a:rPr lang="en-US" dirty="0"/>
               <a:t>Tempo deste diapositivo: 0:45 (relógio no fim: 11:20 de 20:00).
-A H2 foi medida com o protótipo num computador modesto, sem GPU: 0,63 segundos por publicação. Com a gravação por sublotes, as primeiras publicações chegam à fila em 36 segundos, e todas em menos de 60 segundos em recolhas até cerca de 64 publicações. A H3 não pôde ser testada por falta de um corpus datado.</a:t>
+A H2 foi medida com o protótipo num computador modesto, sem GPU: 0,6 a 0,7 segundos por publicação. Com a gravação por sublotes, as primeiras publicações chegam à fila em 36 segundos, e todas em menos de 60 segundos em recolhas até cerca de 64 publicações. A H3 não pôde ser testada por falta de um corpus datado.</a:t>
             </a:r>
             <a:endParaRPr lang="en-US" dirty="0"/>
           </a:p>
@@ -2859,7 +2859,7 @@
             <a:r>
               <a:rPr lang="en-US" dirty="0"/>
               <a:t>Tempo deste diapositivo: 0:55 (relógio no fim: 12:15 de 20:00).
-Antes do sistema, digo o que os resultados não permitem afirmar. O piloto é pequeno, sobretudo na Mobilização Hostil (47 exemplos de teste). 91% do teste é brasileiro. A desinformação disponível são notícias. Não separei língua, plataforma e registo. A utilidade para analistas e a antecipação não foram medidas. E o protótipo não teve auditoria de segurança independente.</a:t>
+Antes do sistema, digo o que os resultados não permitem afirmar. O piloto é pequeno, sobretudo na Mobilização Hostil (47 exemplos de teste). 91% do teste é brasileiro. A desinformação disponível são notícias. Não separei língua, plataforma e registo. As etiquetas do piloto são mais amplas do que as dos corpora públicos. A utilidade para analistas e a antecipação não foram medidas. E o protótipo não teve auditoria de segurança independente.</a:t>
             </a:r>
             <a:endParaRPr lang="en-US" dirty="0"/>
           </a:p>
@@ -2948,7 +2948,7 @@
             <a:r>
               <a:rPr lang="en-US" dirty="0"/>
               <a:t>Tempo deste diapositivo: 1:00 (relógio no fim: 13:15 de 20:00).
-Os resultados ditaram o desenho: o modelo não decide, ordena. Arquitectura leve, num único servidor, software livre e sem dependência da Internet. Salvaguardas: anonimização à entrada, sem perfis, revisão humana obrigatória, auditoria. Passo agora para a demonstração.</a:t>
+Os resultados ditaram o desenho: o modelo não decide, ordena. Arquitectura leve, num único servidor, software livre e sem dependência da Internet. Salvaguardas: pseudonimização à entrada, sem perfis, revisão humana obrigatória, auditoria. Passo agora para a demonstração.</a:t>
             </a:r>
             <a:endParaRPr lang="en-US" dirty="0"/>
           </a:p>
@@ -3037,15 +3037,15 @@
             <a:r>
               <a:rPr lang="en-US" dirty="0"/>
               <a:t>Tempo deste diapositivo: 4:00 (relógio no fim: 17:15 de 20:00).
-ANTES DA SESSÃO: arrancar o servidor com «python uan.py servir --demonstracao», entrar como demo.analista num separador e como demo.supervisor noutro. Ao chegar a este diapositivo, mudar para o navegador (Alt+Tab).
+ANTES DA SESSÃO: arrancar o servidor com arrancar_demonstracao.bat (ou «python uan.py servir --demonstracao»), entrar como demo.supervisor e carregar em Saltar na visita guiada. Ao chegar a este diapositivo, mudar para o navegador (Alt+Tab).
 Roteiro com tempos:
 1) Panorama (0:25): o que foi recolhido e sinalizado.
 2) Fila e amostra de controlo (1:00): ler uma publicação, decidir com a tecla, desfazer com U; mostrar as probabilidades e o realce do lugar; referir a revisão cega; abrir a amostra de controlo.
 3) Alertas e mapa (1:00): sino, mapa com cartão de uma província, reprodução semana a semana.
 4) Sobre o modelo (0:30): o desempenho em Angola, 0,53, está à vista do analista.
-5) Fontes e contas (0:40): recolha automática com a estimativa da quota; ligação «Esqueceu-se da palavra-passe?» e pedido ao supervisor.
+5) Lotes e contas (0:40): cada recolha fica registada como lote; Sair e ligação «Esqueceu-se da palavra-passe?» (na demonstração a recolha automática está desligada).
 Passagens para o navegador e de regresso: 0:25.
-Se a demonstração falhar, usar os diapositivos de reserva A, B e C, no fim.</a:t>
+Se a demonstração falhar, passar o vídeo de reserva (3:24) ou os diapositivos de reserva A, B e C, no fim.</a:t>
             </a:r>
             <a:endParaRPr lang="en-US" dirty="0"/>
           </a:p>
@@ -3312,7 +3312,7 @@
             <a:r>
               <a:rPr lang="en-US" dirty="0"/>
               <a:t>Tempo deste diapositivo: 0:50 (relógio no fim: 19:45 de 20:00).
-As recomendações, separadas das conclusões como pedem as Normas da UAN. As três primeiras são condições para qualquer uso institucional; as outras três são trabalho futuro. Fechar com: o investimento que mais rende são dados angolanos anotados.</a:t>
+As recomendações, num capítulo próprio, separadas das conclusões como pedem as Normas da UAN. As três primeiras são condições para qualquer uso institucional; as outras três são trabalho futuro. Fechar com: o investimento que mais rende são dados angolanos anotados.</a:t>
             </a:r>
             <a:endParaRPr lang="en-US" dirty="0"/>
           </a:p>
@@ -3843,7 +3843,7 @@
             <a:r>
               <a:rPr lang="en-US" dirty="0"/>
               <a:t>Tempo deste diapositivo: 1:00 (relógio no fim: 2:00 de 20:00).
-O fenómeno tem escala: 17,6 milhões de utilizadores da Internet e 5,5 milhões de identidades em redes sociais. Dois episódios mostram o peso político: a campanha «2022 Vais Gostar», que passou das redes para a rua, e os protestos de Agosto de 2025. O problema para as estruturas de segurança é o volume: não é possível ler tudo, e as ferramentas comerciais não foram pensadas para o português de Angola.</a:t>
+O fenómeno tem escala: 17,6 milhões de utilizadores da Internet e 5,5 milhões de identidades em redes sociais. A campanha «2022 Vais Gostar» mostra o peso político: passou das redes para a rua, com manifestações em várias províncias. E a desinformação ganhou ferramentas novas, como deepfakes, bots e campanhas coordenadas. O problema para as estruturas de segurança é o volume: não é possível ler tudo, e as ferramentas comerciais não foram pensadas para o português de Angola.</a:t>
             </a:r>
             <a:endParaRPr lang="en-US" dirty="0"/>
           </a:p>
@@ -5915,7 +5915,7 @@
                   <a:schemeClr val="tx1"/>
                 </a:solidFill>
               </a:rPr>
-              <a:t>BERTimbau, IC 95% de 0,774 a 0,838</a:t>
+              <a:t>BERTimbau, IC 95% de 0,774 a 0,838; média de 3 sementes: 0,797</a:t>
             </a:r>
             <a:endParaRPr lang="en-US" sz="3400" dirty="0"/>
           </a:p>
@@ -6069,7 +6069,7 @@
                   <a:schemeClr val="tx1"/>
                 </a:solidFill>
               </a:rPr>
-              <a:t>O Bi-LSTM não se distingue da Floresta Aleatória</a:t>
+              <a:t>O Bi-LSTM nunca supera a Floresta Aleatória (3 sementes)</a:t>
             </a:r>
             <a:endParaRPr lang="en-US" sz="1400" dirty="0"/>
           </a:p>
@@ -6757,7 +6757,7 @@
                   <a:schemeClr val="tx1"/>
                 </a:solidFill>
               </a:rPr>
-              <a:t>O modelo aprendeu o estilo das notícias do Fake.br, não o fenómeno (aprendizagem de atalhos).</a:t>
+              <a:t>Duas explicações que os dados não separam: estilo das notícias do Fake.br ou etiquetas mais amplas no piloto.</a:t>
             </a:r>
             <a:endParaRPr lang="en-US" sz="1400" dirty="0"/>
           </a:p>
@@ -6799,7 +6799,7 @@
                   <a:schemeClr val="tx1"/>
                 </a:solidFill>
               </a:rPr>
-              <a:t>Piloto pequeno (n = 355); não separa língua, plataforma e registo.</a:t>
+              <a:t>Sem Mobilização Hostil: −37,3 p.p. [30,6; 44,7]. Só YouTube sorteado: 0,535.</a:t>
             </a:r>
             <a:endParaRPr lang="en-US" sz="1400" dirty="0"/>
           </a:p>
@@ -7294,7 +7294,7 @@
                 <a:ea typeface="Arial" pitchFamily="34" charset="-122"/>
                 <a:cs typeface="Arial" pitchFamily="34" charset="-120"/>
               </a:rPr>
-              <a:t>A fila encontra 80% das ameaças em 25% da leitura</a:t>
+              <a:t>No teste, 25% da ordenação encontra 80% das ameaças</a:t>
             </a:r>
             <a:endParaRPr lang="en-US" sz="2800" dirty="0"/>
           </a:p>
@@ -7346,7 +7346,7 @@
                   <a:schemeClr val="tx1"/>
                 </a:solidFill>
               </a:rPr>
-              <a:t>Figura 5 – Curva de esforço de revisão no conjunto de teste</a:t>
+              <a:t>Figura 5 – Curva de esforço numa ordenação de todo o conjunto de teste</a:t>
             </a:r>
             <a:endParaRPr lang="en-US" sz="1000" dirty="0"/>
           </a:p>
@@ -7445,7 +7445,7 @@
                   <a:schemeClr val="tx1"/>
                 </a:solidFill>
               </a:rPr>
-              <a:t>da fila revista encontra 80% das ameaças (BERTimbau)</a:t>
+              <a:t>da ordenação revista encontra 80% das ameaças (BERTimbau, teste); no piloto, 49%</a:t>
             </a:r>
             <a:endParaRPr lang="en-US" sz="1200" dirty="0"/>
           </a:p>
@@ -7607,7 +7607,7 @@
                   <a:srgbClr val="9A7400"/>
                 </a:solidFill>
               </a:rPr>
-              <a:t>11,8%</a:t>
+              <a:t>28,7%</a:t>
             </a:r>
             <a:endParaRPr lang="en-US" sz="2600" dirty="0"/>
           </a:p>
@@ -7643,7 +7643,7 @@
                   <a:schemeClr val="tx1"/>
                 </a:solidFill>
               </a:rPr>
-              <a:t>das ameaças ficam entre os Normais: daí a amostra de controlo</a:t>
+              <a:t>das ameaças angolanas ficam entre os Normais (11,8% no teste): daí a amostra de controlo</a:t>
             </a:r>
             <a:endParaRPr lang="en-US" sz="1200" dirty="0"/>
           </a:p>
@@ -8138,7 +8138,7 @@
                 <a:ea typeface="Arial" pitchFamily="34" charset="-122"/>
                 <a:cs typeface="Arial" pitchFamily="34" charset="-120"/>
               </a:rPr>
-              <a:t>Cada publicação é processada em 0,63 s, sem GPU (H2)</a:t>
+              <a:t>Cada publicação é processada em 0,6–0,7 s, sem GPU (H2)</a:t>
             </a:r>
             <a:endParaRPr lang="en-US" sz="2800" dirty="0"/>
           </a:p>
@@ -8250,7 +8250,7 @@
                   <a:srgbClr val="102A43"/>
                 </a:solidFill>
               </a:rPr>
-              <a:t>0,63 s</a:t>
+              <a:t>0,6–0,7 s</a:t>
             </a:r>
             <a:endParaRPr lang="en-US" sz="3600" dirty="0"/>
           </a:p>
@@ -9842,7 +9842,7 @@
                   <a:schemeClr val="tx1"/>
                 </a:solidFill>
               </a:rPr>
-              <a:t>Língua, plataforma e registo variam ao mesmo tempo no piloto</a:t>
+              <a:t>Língua, plataforma, registo e construto das etiquetas variam ao mesmo tempo</a:t>
             </a:r>
             <a:endParaRPr lang="en-US" sz="1300" dirty="0"/>
           </a:p>
@@ -10814,7 +10814,7 @@
                   <a:srgbClr val="102A43"/>
                 </a:solidFill>
               </a:rPr>
-              <a:t>Anonimização à entrada</a:t>
+              <a:t>Pseudonimização à entrada</a:t>
             </a:r>
             <a:endParaRPr lang="en-US" sz="1400" dirty="0"/>
           </a:p>
@@ -12503,7 +12503,7 @@
                   <a:srgbClr val="102A43"/>
                 </a:solidFill>
               </a:rPr>
-              <a:t>Fontes e contas</a:t>
+              <a:t>Lotes e contas</a:t>
             </a:r>
             <a:endParaRPr lang="en-US" sz="1600" dirty="0"/>
           </a:p>
@@ -12517,7 +12517,7 @@
                   <a:schemeClr val="tx1"/>
                 </a:solidFill>
               </a:rPr>
-              <a:t>Recolha automática, quota do YouTube, recuperação do acesso</a:t>
+              <a:t>Registo de cada recolha, recuperação do acesso</a:t>
             </a:r>
             <a:endParaRPr lang="en-US" sz="1600" dirty="0"/>
           </a:p>
@@ -13565,7 +13565,7 @@
                             <a:srgbClr val="1B2733"/>
                           </a:solidFill>
                         </a:rPr>
-                        <a:t>BERTimbau +14,6 a +17,4 p.p., p &lt; 10⁻⁴⁷; Bi-LSTM igual à Floresta Aleatória</a:t>
+                        <a:t>BERTimbau +14,6 a +17,4 p.p., p &lt; 10⁻⁴⁷; Bi-LSTM nunca supera a Floresta Aleatória (3 sementes)</a:t>
                       </a:r>
                       <a:endParaRPr lang="en-US" sz="1400" dirty="0"/>
                     </a:p>
@@ -13744,7 +13744,7 @@
                             <a:srgbClr val="1B2733"/>
                           </a:solidFill>
                         </a:rPr>
-                        <a:t>0,63 s em CPU; primeiras na fila em 36 s; todas em &lt; 60 s até 64 por recolha</a:t>
+                        <a:t>0,6–0,7 s em CPU; primeiras na fila em 36 s; todas em &lt; 60 s até 64 por recolha</a:t>
                       </a:r>
                       <a:endParaRPr lang="en-US" sz="1400" dirty="0"/>
                     </a:p>
@@ -16467,7 +16467,7 @@
                   <a:srgbClr val="5B6B7F"/>
                 </a:solidFill>
               </a:rPr>
-              <a:t>Fonte: Secção 5.7 da dissertação (nove recomendações; aqui as seis principais).</a:t>
+              <a:t>Fonte: Capítulo 6 da dissertação (oito recomendações; aqui as seis principais).</a:t>
             </a:r>
             <a:endParaRPr lang="en-US" sz="1000" dirty="0"/>
           </a:p>
@@ -20434,7 +20434,7 @@
                   <a:schemeClr val="tx1"/>
                 </a:solidFill>
               </a:rPr>
-              <a:t>A campanha «2022 Vais Gostar» começou nas redes e terminou em manifestações em várias províncias (Hassane, 2021).</a:t>
+              <a:t>A campanha «2022 Vais Gostar» começou nas redes e terminou em manifestações em várias províncias (Hassane, 2021, pp. 37–38).</a:t>
             </a:r>
             <a:endParaRPr lang="en-US" sz="1400" dirty="0"/>
           </a:p>
@@ -20452,7 +20452,7 @@
                   <a:schemeClr val="tx1"/>
                 </a:solidFill>
               </a:rPr>
-              <a:t>Nos protestos de Agosto de 2025 circularam conteúdos sintéticos para influenciar a narrativa (Cintra, 2025).</a:t>
+              <a:t>A desinformação ganhou ferramentas novas: deepfakes, bots e campanhas coordenadas (Cintra, 2025, p. 101).</a:t>
             </a:r>
             <a:endParaRPr lang="en-US" sz="1400" dirty="0"/>
           </a:p>
@@ -23452,7 +23452,7 @@
                   <a:schemeClr val="tx1"/>
                 </a:solidFill>
               </a:rPr>
-              <a:t>Programas e plataformas internacionais sem português de Angola ou com dependência de fornecedores externos (Defense Advanced Research Projects Agency, 2016; Palantir Technologies, 2021).</a:t>
+              <a:t>Programas e plataformas internacionais sem português de Angola ou com dependência de fornecedores externos (Defense Advanced Research Projects Agency, 2016; Palantir Technologies, 2024).</a:t>
             </a:r>
             <a:endParaRPr lang="en-US" sz="1300" dirty="0"/>
           </a:p>
@@ -24621,7 +24621,7 @@
                   <a:schemeClr val="tx1"/>
                 </a:solidFill>
               </a:rPr>
-              <a:t>Só conteúdo público, anonimização à entrada, Lei n.º 22/11</a:t>
+              <a:t>Só conteúdo público, pseudonimização à entrada, Lei n.º 22/11</a:t>
             </a:r>
             <a:endParaRPr lang="en-US" sz="1400" dirty="0"/>
           </a:p>
@@ -25245,7 +25245,7 @@
                   <a:schemeClr val="tx1"/>
                 </a:solidFill>
               </a:rPr>
-              <a:t>κ de Fleiss: acordo substancial</a:t>
+              <a:t>κ de Fleiss (n = 2 443): acordo substancial</a:t>
             </a:r>
             <a:endParaRPr lang="en-US" sz="4000" dirty="0"/>
           </a:p>
@@ -25362,7 +25362,7 @@
                   <a:schemeClr val="tx1"/>
                 </a:solidFill>
               </a:rPr>
-              <a:t>Autores anonimizados antes de gravar (pseudónimo HMAC)</a:t>
+              <a:t>Autores pseudonimizados antes de gravar (HMAC)</a:t>
             </a:r>
             <a:endParaRPr lang="en-US" sz="1400" dirty="0"/>
           </a:p>

</xml_diff>